<commit_message>
Add benefits/drawbacks discussion + ship deployment artifacts
Report (docs/project-report.md + submission PDF): new "Potential benefits
and drawbacks" section covering forward-looking awareness, measurable
efficiency, reproducibility, vendor-independence and pilot cost, against
data gaps, unvalidated-model risk, privacy/liability, external dependency,
equity and false-confidence risks; test counts updated to 451.

Deck (docs/presentation.md + presentation-notes.md + PPTX/PDF): new
Slide 11 "Potential Benefits & Drawbacks", renumbered to 13 slides,
Slide 12 now covers Limitations / Future / Deployed; 451 tests.

render.yaml: Render Blueprint for a single-URL Web Service (schema migrate
at boot, Uvicorn on $PORT, real TomTom collection enabled)
</commit_message>
<xml_diff>
--- a/submission/AI_Traffic_Congestion_Prediction_Presentation.pptx
+++ b/submission/AI_Traffic_Congestion_Prediction_Presentation.pptx
@@ -17,6 +17,7 @@
     <p:sldId id="265" r:id="rId17"/>
     <p:sldId id="266" r:id="rId18"/>
     <p:sldId id="267" r:id="rId19"/>
+    <p:sldId id="268" r:id="rId20"/>
   </p:sldIdLst>
   <p:sldSz cx="12191695" cy="6858000" type="screen4x3"/>
   <p:notesSz cx="6858000" cy="9144000"/>
@@ -583,7 +584,7 @@
           <a:lstStyle/>
           <a:p>
             <a:r>
-              <a:t>450 tests, no external services. Results are demo-only: macro F1 0.737, accuracy 0.856 vs baseline 0.214/0.750. Not real-traffic claims.</a:t>
+              <a:t>451 tests, no external services. Results are demo-only: macro F1 0.737, accuracy 0.856 vs baseline 0.214/0.750. Not real-traffic claims.</a:t>
             </a:r>
           </a:p>
         </p:txBody>
@@ -653,7 +654,7 @@
           <a:lstStyle/>
           <a:p>
             <a:r>
-              <a:t>Honest scope: benefits of the engineering, limitations stated clearly, next steps. Nothing fabricated.</a:t>
+              <a:t>Discuss benefits then drawbacks. The honest ones are engineered in (labelling, provenance, production guard); the rest are stated in the report.</a:t>
             </a:r>
           </a:p>
         </p:txBody>
@@ -723,7 +724,77 @@
           <a:lstStyle/>
           <a:p>
             <a:r>
-              <a:t>Closing. Honest scope + next steps. Questions.</a:t>
+              <a:t>Honest scope, then what is already shipped and running: Docker, CI, and the public single-URL demo.</a:t>
+            </a:r>
+          </a:p>
+        </p:txBody>
+      </p:sp>
+      <p:sp>
+        <p:nvSpPr>
+          <p:cNvPr id="4" name="Slide Number Placeholder 3"/>
+          <p:cNvSpPr>
+            <a:spLocks noGrp="1"/>
+          </p:cNvSpPr>
+          <p:nvPr>
+            <p:ph type="sldNum" idx="5" sz="quarter"/>
+          </p:nvPr>
+        </p:nvSpPr>
+        <p:spPr/>
+      </p:sp>
+    </p:spTree>
+  </p:cSld>
+  <p:clrMapOvr>
+    <a:masterClrMapping/>
+  </p:clrMapOvr>
+</p:notes>
+</file>
+
+<file path=ppt/notesSlides/notesSlide13.xml><?xml version="1.0" encoding="utf-8"?>
+<p:notes xmlns:a="http://schemas.openxmlformats.org/drawingml/2006/main" xmlns:p="http://schemas.openxmlformats.org/presentationml/2006/main" xmlns:r="http://schemas.openxmlformats.org/officeDocument/2006/relationships">
+  <p:cSld>
+    <p:spTree>
+      <p:nvGrpSpPr>
+        <p:cNvPr id="1" name=""/>
+        <p:cNvGrpSpPr/>
+        <p:nvPr/>
+      </p:nvGrpSpPr>
+      <p:grpSpPr>
+        <a:xfrm>
+          <a:off x="0" y="0"/>
+          <a:ext cx="0" cy="0"/>
+          <a:chOff x="0" y="0"/>
+          <a:chExt cx="0" cy="0"/>
+        </a:xfrm>
+      </p:grpSpPr>
+      <p:sp>
+        <p:nvSpPr>
+          <p:cNvPr id="2" name="Slide Image Placeholder 1"/>
+          <p:cNvSpPr>
+            <a:spLocks noGrp="1"/>
+          </p:cNvSpPr>
+          <p:nvPr>
+            <p:ph type="sldImg" idx="2"/>
+          </p:nvPr>
+        </p:nvSpPr>
+        <p:spPr/>
+      </p:sp>
+      <p:sp>
+        <p:nvSpPr>
+          <p:cNvPr id="3" name="Notes Placeholder 2"/>
+          <p:cNvSpPr>
+            <a:spLocks noGrp="1"/>
+          </p:cNvSpPr>
+          <p:nvPr>
+            <p:ph type="body" idx="3" sz="quarter"/>
+          </p:nvPr>
+        </p:nvSpPr>
+        <p:spPr/>
+        <p:txBody>
+          <a:bodyPr/>
+          <a:lstStyle/>
+          <a:p>
+            <a:r>
+              <a:t>Closing. Honest scope + live deployment + next steps. Questions.</a:t>
             </a:r>
           </a:p>
         </p:txBody>
@@ -4720,7 +4791,7 @@
                 </a:solidFill>
                 <a:latin typeface="Calibri"/>
               </a:rPr>
-              <a:t>450 automated tests passing</a:t>
+              <a:t>451 automated tests passing</a:t>
             </a:r>
           </a:p>
         </p:txBody>
@@ -5240,7 +5311,7 @@
                 </a:solidFill>
                 <a:latin typeface="Calibri"/>
               </a:rPr>
-              <a:t>Verification – 450 automated tests</a:t>
+              <a:t>Verification – 451 automated tests</a:t>
             </a:r>
             <a:r>
               <a:rPr sz="1300" b="0" i="0">
@@ -5719,7 +5790,7 @@
                 </a:solidFill>
                 <a:latin typeface="Calibri"/>
               </a:rPr>
-              <a:t>Benefits · Limitations · Future</a:t>
+              <a:t>Potential Benefits &amp; Drawbacks</a:t>
             </a:r>
           </a:p>
         </p:txBody>
@@ -5885,7 +5956,7 @@
         <p:spPr>
           <a:xfrm>
             <a:off x="822960" y="1737360"/>
-            <a:ext cx="3520440" cy="4023360"/>
+            <a:ext cx="5257800" cy="3977639"/>
           </a:xfrm>
           <a:prstGeom prst="roundRect">
             <a:avLst>
@@ -5944,7 +6015,7 @@
                 </a:solidFill>
                 <a:latin typeface="Calibri"/>
               </a:rPr>
-              <a:t>–  honest, fully labelled pipeline</a:t>
+              <a:t>–  forward-looking – reroute before congestion, not inside it</a:t>
             </a:r>
           </a:p>
           <a:p>
@@ -5960,7 +6031,7 @@
                 </a:solidFill>
                 <a:latin typeface="Calibri"/>
               </a:rPr>
-              <a:t>–  leakage-safe evaluation with baseline</a:t>
+              <a:t>–  less idling → saved travel time, fuel and emissions</a:t>
             </a:r>
           </a:p>
           <a:p>
@@ -5976,7 +6047,7 @@
                 </a:solidFill>
                 <a:latin typeface="Calibri"/>
               </a:rPr>
-              <a:t>–  retraining-ready for a real dataset</a:t>
+              <a:t>–  reproducible, inspectable model, not arbitrary threshold rules</a:t>
             </a:r>
           </a:p>
           <a:p>
@@ -5992,7 +6063,7 @@
                 </a:solidFill>
                 <a:latin typeface="Calibri"/>
               </a:rPr>
-              <a:t>–  provenance removes feature skew</a:t>
+              <a:t>–  one provider interface – retraining-ready on real data</a:t>
             </a:r>
           </a:p>
           <a:p>
@@ -6008,23 +6079,7 @@
                 </a:solidFill>
                 <a:latin typeface="Calibri"/>
               </a:rPr>
-              <a:t>–  production guard + XSS hardening</a:t>
-            </a:r>
-          </a:p>
-          <a:p>
-            <a:pPr>
-              <a:spcBef>
-                <a:spcPts val="300"/>
-              </a:spcBef>
-            </a:pPr>
-            <a:r>
-              <a:rPr sz="1100">
-                <a:solidFill>
-                  <a:srgbClr val="595959"/>
-                </a:solidFill>
-                <a:latin typeface="Calibri"/>
-              </a:rPr>
-              <a:t>–  no external services needed to test</a:t>
+              <a:t>–  cheap to pilot on free-tier sources (TomTom, keyless Open-Meteo)</a:t>
             </a:r>
           </a:p>
         </p:txBody>
@@ -6037,8 +6092,8 @@
         </p:nvSpPr>
         <p:spPr>
           <a:xfrm>
-            <a:off x="4526280" y="1737360"/>
-            <a:ext cx="3520440" cy="4023360"/>
+            <a:off x="6263640" y="1737360"/>
+            <a:ext cx="5120640" cy="3977639"/>
           </a:xfrm>
           <a:prstGeom prst="roundRect">
             <a:avLst>
@@ -6081,7 +6136,7 @@
                 </a:solidFill>
                 <a:latin typeface="Calibri"/>
               </a:rPr>
-              <a:t>Limitations</a:t>
+              <a:t>Drawbacks</a:t>
             </a:r>
           </a:p>
           <a:p>
@@ -6097,7 +6152,7 @@
                 </a:solidFill>
                 <a:latin typeface="Calibri"/>
               </a:rPr>
-              <a:t>–  training data is a simulated fixture</a:t>
+              <a:t>–  data gaps: current-conditions-only, quota-limited, no throughput</a:t>
             </a:r>
           </a:p>
           <a:p>
@@ -6113,7 +6168,7 @@
                 </a:solidFill>
                 <a:latin typeface="Calibri"/>
               </a:rPr>
-              <a:t>–  vehicle_count NULL on live readings</a:t>
+              <a:t>–  six prior readings per location before any forecast is possible</a:t>
             </a:r>
           </a:p>
           <a:p>
@@ -6129,7 +6184,7 @@
                 </a:solidFill>
                 <a:latin typeface="Calibri"/>
               </a:rPr>
-              <a:t>–  no historical feed yet – scheduler accumulates it</a:t>
+              <a:t>–  simulated-data model – demonstrative until revalidated</a:t>
             </a:r>
           </a:p>
           <a:p>
@@ -6145,7 +6200,23 @@
                 </a:solidFill>
                 <a:latin typeface="Calibri"/>
               </a:rPr>
-              <a:t>–  API unauthenticated until a gateway is added</a:t>
+              <a:t>–  privacy and liability around derived travel behaviour</a:t>
+            </a:r>
+          </a:p>
+          <a:p>
+            <a:pPr>
+              <a:spcBef>
+                <a:spcPts val="300"/>
+              </a:spcBef>
+            </a:pPr>
+            <a:r>
+              <a:rPr sz="1100">
+                <a:solidFill>
+                  <a:srgbClr val="595959"/>
+                </a:solidFill>
+                <a:latin typeface="Calibri"/>
+              </a:rPr>
+              <a:t>–  vendor dependence · equity · false-confidence risk</a:t>
             </a:r>
           </a:p>
         </p:txBody>
@@ -6158,21 +6229,19 @@
         </p:nvSpPr>
         <p:spPr>
           <a:xfrm>
-            <a:off x="8229600" y="1737360"/>
-            <a:ext cx="3154680" cy="4023360"/>
+            <a:off x="822960" y="5897880"/>
+            <a:ext cx="10545775" cy="502920"/>
           </a:xfrm>
           <a:prstGeom prst="roundRect">
             <a:avLst>
-              <a:gd name="adj" fmla="val 10000"/>
+              <a:gd name="adj" fmla="val 6000"/>
             </a:avLst>
           </a:prstGeom>
           <a:solidFill>
-            <a:srgbClr val="F2F6FC"/>
+            <a:srgbClr val="DCE6F1"/>
           </a:solidFill>
-          <a:ln w="9525">
-            <a:solidFill>
-              <a:srgbClr val="2E74B5"/>
-            </a:solidFill>
+          <a:ln>
+            <a:noFill/>
           </a:ln>
           <a:effectLst/>
         </p:spPr>
@@ -6191,82 +6260,25 @@
           </a:fontRef>
         </p:style>
         <p:txBody>
-          <a:bodyPr rtlCol="0" anchor="t" wrap="square" lIns="128016" rIns="128016" tIns="73152"/>
-          <a:lstStyle/>
-          <a:p>
-            <a:pPr algn="ctr"/>
-            <a:r>
-              <a:rPr b="1" sz="1300">
+          <a:bodyPr rtlCol="0" anchor="ctr" wrap="square" lIns="182880" rIns="182880"/>
+          <a:lstStyle/>
+          <a:p>
+            <a:pPr algn="ctr">
+              <a:spcBef>
+                <a:spcPts val="0"/>
+              </a:spcBef>
+              <a:spcAft>
+                <a:spcPts val="400"/>
+              </a:spcAft>
+            </a:pPr>
+            <a:r>
+              <a:rPr sz="1300" b="1" i="0">
                 <a:solidFill>
                   <a:srgbClr val="1F3864"/>
                 </a:solidFill>
                 <a:latin typeface="Calibri"/>
               </a:rPr>
-              <a:t>Future</a:t>
-            </a:r>
-          </a:p>
-          <a:p>
-            <a:pPr>
-              <a:spcBef>
-                <a:spcPts val="300"/>
-              </a:spcBef>
-            </a:pPr>
-            <a:r>
-              <a:rPr sz="1100">
-                <a:solidFill>
-                  <a:srgbClr val="595959"/>
-                </a:solidFill>
-                <a:latin typeface="Calibri"/>
-              </a:rPr>
-              <a:t>–  retrain + revalidate on real ground truth</a:t>
-            </a:r>
-          </a:p>
-          <a:p>
-            <a:pPr>
-              <a:spcBef>
-                <a:spcPts val="300"/>
-              </a:spcBef>
-            </a:pPr>
-            <a:r>
-              <a:rPr sz="1100">
-                <a:solidFill>
-                  <a:srgbClr val="595959"/>
-                </a:solidFill>
-                <a:latin typeface="Calibri"/>
-              </a:rPr>
-              <a:t>–  Docker image + CI running the suite</a:t>
-            </a:r>
-          </a:p>
-          <a:p>
-            <a:pPr>
-              <a:spcBef>
-                <a:spcPts val="300"/>
-              </a:spcBef>
-            </a:pPr>
-            <a:r>
-              <a:rPr sz="1100">
-                <a:solidFill>
-                  <a:srgbClr val="595959"/>
-                </a:solidFill>
-                <a:latin typeface="Calibri"/>
-              </a:rPr>
-              <a:t>–  gateway auth and rate limiting</a:t>
-            </a:r>
-          </a:p>
-          <a:p>
-            <a:pPr>
-              <a:spcBef>
-                <a:spcPts val="300"/>
-              </a:spcBef>
-            </a:pPr>
-            <a:r>
-              <a:rPr sz="1100">
-                <a:solidFill>
-                  <a:srgbClr val="595959"/>
-                </a:solidFill>
-                <a:latin typeface="Calibri"/>
-              </a:rPr>
-              <a:t>–  live TomTom + PostgreSQL round-trip</a:t>
+              <a:t>The honest drawbacks are designed in – labelling, provenance, production guard; the rest are named in the report.</a:t>
             </a:r>
           </a:p>
         </p:txBody>
@@ -6298,7 +6310,7 @@
         <p:spPr>
           <a:xfrm>
             <a:off x="0" y="0"/>
-            <a:ext cx="12191695" cy="6858000"/>
+            <a:ext cx="12191695" cy="1234440"/>
           </a:xfrm>
           <a:prstGeom prst="rect">
             <a:avLst/>
@@ -6335,14 +6347,58 @@
       </p:sp>
       <p:sp>
         <p:nvSpPr>
-          <p:cNvPr id="3" name="TextBox 2"/>
+          <p:cNvPr id="3" name="Rectangle 2"/>
+          <p:cNvSpPr/>
+          <p:nvPr/>
+        </p:nvSpPr>
+        <p:spPr>
+          <a:xfrm>
+            <a:off x="0" y="1234440"/>
+            <a:ext cx="12191695" cy="41148"/>
+          </a:xfrm>
+          <a:prstGeom prst="rect">
+            <a:avLst/>
+          </a:prstGeom>
+          <a:solidFill>
+            <a:srgbClr val="2E74B5"/>
+          </a:solidFill>
+          <a:ln>
+            <a:noFill/>
+          </a:ln>
+          <a:effectLst/>
+        </p:spPr>
+        <p:style>
+          <a:lnRef idx="1">
+            <a:schemeClr val="accent1"/>
+          </a:lnRef>
+          <a:fillRef idx="3">
+            <a:schemeClr val="accent1"/>
+          </a:fillRef>
+          <a:effectRef idx="2">
+            <a:schemeClr val="accent1"/>
+          </a:effectRef>
+          <a:fontRef idx="minor">
+            <a:schemeClr val="lt1"/>
+          </a:fontRef>
+        </p:style>
+        <p:txBody>
+          <a:bodyPr rtlCol="0" anchor="ctr"/>
+          <a:lstStyle/>
+          <a:p>
+            <a:pPr algn="ctr"/>
+          </a:p>
+        </p:txBody>
+      </p:sp>
+      <p:sp>
+        <p:nvSpPr>
+          <p:cNvPr id="4" name="TextBox 3"/>
           <p:cNvSpPr txBox="1"/>
           <p:nvPr/>
         </p:nvSpPr>
         <p:spPr>
           <a:xfrm>
-            <a:off x="822960" y="1188720"/>
-            <a:ext cx="10545775" cy="457200"/>
+            <a:off x="548640" y="109728"/>
+            <a:ext cx="11094415" cy="292608"/>
           </a:xfrm>
           <a:prstGeom prst="rect">
             <a:avLst/>
@@ -6355,7 +6411,7 @@
           </a:bodyPr>
           <a:lstStyle/>
           <a:p>
-            <a:pPr algn="ctr">
+            <a:pPr algn="l">
               <a:spcBef>
                 <a:spcPts val="0"/>
               </a:spcBef>
@@ -6364,27 +6420,27 @@
               </a:spcAft>
             </a:pPr>
             <a:r>
-              <a:rPr sz="1300" b="1" i="0">
+              <a:rPr sz="1100" b="1" i="0">
                 <a:solidFill>
                   <a:srgbClr val="9DC3E6"/>
                 </a:solidFill>
                 <a:latin typeface="Calibri"/>
               </a:rPr>
-              <a:t>SLIDE 12 · CONCLUSION</a:t>
-            </a:r>
-          </a:p>
-        </p:txBody>
-      </p:sp>
-      <p:sp>
-        <p:nvSpPr>
-          <p:cNvPr id="4" name="TextBox 3"/>
+              <a:t>SLIDE 12</a:t>
+            </a:r>
+          </a:p>
+        </p:txBody>
+      </p:sp>
+      <p:sp>
+        <p:nvSpPr>
+          <p:cNvPr id="5" name="TextBox 4"/>
           <p:cNvSpPr txBox="1"/>
           <p:nvPr/>
         </p:nvSpPr>
         <p:spPr>
           <a:xfrm>
-            <a:off x="822960" y="1645920"/>
-            <a:ext cx="10545775" cy="822960"/>
+            <a:off x="548640" y="384048"/>
+            <a:ext cx="11094415" cy="777240"/>
           </a:xfrm>
           <a:prstGeom prst="rect">
             <a:avLst/>
@@ -6397,7 +6453,7 @@
           </a:bodyPr>
           <a:lstStyle/>
           <a:p>
-            <a:pPr algn="ctr">
+            <a:pPr algn="l">
               <a:spcBef>
                 <a:spcPts val="0"/>
               </a:spcBef>
@@ -6406,27 +6462,71 @@
               </a:spcAft>
             </a:pPr>
             <a:r>
-              <a:rPr sz="3400" b="1" i="0">
+              <a:rPr sz="2900" b="1" i="0">
                 <a:solidFill>
                   <a:srgbClr val="FFFFFF"/>
                 </a:solidFill>
                 <a:latin typeface="Calibri"/>
               </a:rPr>
-              <a:t>A working, honest end-to-end pipeline</a:t>
-            </a:r>
-          </a:p>
-        </p:txBody>
-      </p:sp>
-      <p:sp>
-        <p:nvSpPr>
-          <p:cNvPr id="5" name="TextBox 4"/>
+              <a:t>Limitations · Future · Deployed</a:t>
+            </a:r>
+          </a:p>
+        </p:txBody>
+      </p:sp>
+      <p:sp>
+        <p:nvSpPr>
+          <p:cNvPr id="6" name="Rectangle 5"/>
+          <p:cNvSpPr/>
+          <p:nvPr/>
+        </p:nvSpPr>
+        <p:spPr>
+          <a:xfrm>
+            <a:off x="548640" y="6528816"/>
+            <a:ext cx="11094415" cy="12801"/>
+          </a:xfrm>
+          <a:prstGeom prst="rect">
+            <a:avLst/>
+          </a:prstGeom>
+          <a:solidFill>
+            <a:srgbClr val="DCE6F1"/>
+          </a:solidFill>
+          <a:ln>
+            <a:noFill/>
+          </a:ln>
+          <a:effectLst/>
+        </p:spPr>
+        <p:style>
+          <a:lnRef idx="1">
+            <a:schemeClr val="accent1"/>
+          </a:lnRef>
+          <a:fillRef idx="3">
+            <a:schemeClr val="accent1"/>
+          </a:fillRef>
+          <a:effectRef idx="2">
+            <a:schemeClr val="accent1"/>
+          </a:effectRef>
+          <a:fontRef idx="minor">
+            <a:schemeClr val="lt1"/>
+          </a:fontRef>
+        </p:style>
+        <p:txBody>
+          <a:bodyPr rtlCol="0" anchor="ctr"/>
+          <a:lstStyle/>
+          <a:p>
+            <a:pPr algn="ctr"/>
+          </a:p>
+        </p:txBody>
+      </p:sp>
+      <p:sp>
+        <p:nvSpPr>
+          <p:cNvPr id="7" name="TextBox 6"/>
           <p:cNvSpPr txBox="1"/>
           <p:nvPr/>
         </p:nvSpPr>
         <p:spPr>
           <a:xfrm>
-            <a:off x="1463040" y="2651760"/>
-            <a:ext cx="9265615" cy="2377440"/>
+            <a:off x="548640" y="6565392"/>
+            <a:ext cx="11094415" cy="228600"/>
           </a:xfrm>
           <a:prstGeom prst="rect">
             <a:avLst/>
@@ -6438,6 +6538,623 @@
             <a:spAutoFit/>
           </a:bodyPr>
           <a:lstStyle/>
+          <a:p/>
+        </p:txBody>
+      </p:sp>
+      <p:sp>
+        <p:nvSpPr>
+          <p:cNvPr id="8" name="TextBox 7"/>
+          <p:cNvSpPr txBox="1"/>
+          <p:nvPr/>
+        </p:nvSpPr>
+        <p:spPr>
+          <a:xfrm>
+            <a:off x="548640" y="6565392"/>
+            <a:ext cx="8229600" cy="228600"/>
+          </a:xfrm>
+          <a:prstGeom prst="rect">
+            <a:avLst/>
+          </a:prstGeom>
+          <a:noFill/>
+        </p:spPr>
+        <p:txBody>
+          <a:bodyPr wrap="square" anchor="t">
+            <a:spAutoFit/>
+          </a:bodyPr>
+          <a:lstStyle/>
+          <a:p>
+            <a:pPr algn="l">
+              <a:spcBef>
+                <a:spcPts val="0"/>
+              </a:spcBef>
+              <a:spcAft>
+                <a:spcPts val="400"/>
+              </a:spcAft>
+            </a:pPr>
+            <a:r>
+              <a:rPr sz="1000" b="0" i="0">
+                <a:solidFill>
+                  <a:srgbClr val="595959"/>
+                </a:solidFill>
+                <a:latin typeface="Calibri"/>
+              </a:rPr>
+              <a:t>AI-Based Urban Traffic Congestion Prediction System</a:t>
+            </a:r>
+          </a:p>
+        </p:txBody>
+      </p:sp>
+      <p:sp>
+        <p:nvSpPr>
+          <p:cNvPr id="9" name="TextBox 8"/>
+          <p:cNvSpPr txBox="1"/>
+          <p:nvPr/>
+        </p:nvSpPr>
+        <p:spPr>
+          <a:xfrm>
+            <a:off x="8595360" y="6565392"/>
+            <a:ext cx="3017520" cy="228600"/>
+          </a:xfrm>
+          <a:prstGeom prst="rect">
+            <a:avLst/>
+          </a:prstGeom>
+          <a:noFill/>
+        </p:spPr>
+        <p:txBody>
+          <a:bodyPr wrap="square" anchor="t">
+            <a:spAutoFit/>
+          </a:bodyPr>
+          <a:lstStyle/>
+          <a:p>
+            <a:pPr algn="r">
+              <a:spcBef>
+                <a:spcPts val="0"/>
+              </a:spcBef>
+              <a:spcAft>
+                <a:spcPts val="400"/>
+              </a:spcAft>
+            </a:pPr>
+            <a:r>
+              <a:rPr sz="1000" b="0" i="0">
+                <a:solidFill>
+                  <a:srgbClr val="595959"/>
+                </a:solidFill>
+                <a:latin typeface="Calibri"/>
+              </a:rPr>
+              <a:t>Page 12</a:t>
+            </a:r>
+          </a:p>
+        </p:txBody>
+      </p:sp>
+      <p:sp>
+        <p:nvSpPr>
+          <p:cNvPr id="10" name="Rounded Rectangle 9"/>
+          <p:cNvSpPr/>
+          <p:nvPr/>
+        </p:nvSpPr>
+        <p:spPr>
+          <a:xfrm>
+            <a:off x="822960" y="1737360"/>
+            <a:ext cx="3520440" cy="4023360"/>
+          </a:xfrm>
+          <a:prstGeom prst="roundRect">
+            <a:avLst>
+              <a:gd name="adj" fmla="val 10000"/>
+            </a:avLst>
+          </a:prstGeom>
+          <a:solidFill>
+            <a:srgbClr val="F2F6FC"/>
+          </a:solidFill>
+          <a:ln w="9525">
+            <a:solidFill>
+              <a:srgbClr val="2E74B5"/>
+            </a:solidFill>
+          </a:ln>
+          <a:effectLst/>
+        </p:spPr>
+        <p:style>
+          <a:lnRef idx="1">
+            <a:schemeClr val="accent1"/>
+          </a:lnRef>
+          <a:fillRef idx="3">
+            <a:schemeClr val="accent1"/>
+          </a:fillRef>
+          <a:effectRef idx="2">
+            <a:schemeClr val="accent1"/>
+          </a:effectRef>
+          <a:fontRef idx="minor">
+            <a:schemeClr val="lt1"/>
+          </a:fontRef>
+        </p:style>
+        <p:txBody>
+          <a:bodyPr rtlCol="0" anchor="t" wrap="square" lIns="128016" rIns="128016" tIns="73152"/>
+          <a:lstStyle/>
+          <a:p>
+            <a:pPr algn="ctr"/>
+            <a:r>
+              <a:rPr b="1" sz="1300">
+                <a:solidFill>
+                  <a:srgbClr val="1F3864"/>
+                </a:solidFill>
+                <a:latin typeface="Calibri"/>
+              </a:rPr>
+              <a:t>Limitations</a:t>
+            </a:r>
+          </a:p>
+          <a:p>
+            <a:pPr>
+              <a:spcBef>
+                <a:spcPts val="300"/>
+              </a:spcBef>
+            </a:pPr>
+            <a:r>
+              <a:rPr sz="1100">
+                <a:solidFill>
+                  <a:srgbClr val="595959"/>
+                </a:solidFill>
+                <a:latin typeface="Calibri"/>
+              </a:rPr>
+              <a:t>–  training data is a simulated fixture</a:t>
+            </a:r>
+          </a:p>
+          <a:p>
+            <a:pPr>
+              <a:spcBef>
+                <a:spcPts val="300"/>
+              </a:spcBef>
+            </a:pPr>
+            <a:r>
+              <a:rPr sz="1100">
+                <a:solidFill>
+                  <a:srgbClr val="595959"/>
+                </a:solidFill>
+                <a:latin typeface="Calibri"/>
+              </a:rPr>
+              <a:t>–  vehicle_count NULL on live readings</a:t>
+            </a:r>
+          </a:p>
+          <a:p>
+            <a:pPr>
+              <a:spcBef>
+                <a:spcPts val="300"/>
+              </a:spcBef>
+            </a:pPr>
+            <a:r>
+              <a:rPr sz="1100">
+                <a:solidFill>
+                  <a:srgbClr val="595959"/>
+                </a:solidFill>
+                <a:latin typeface="Calibri"/>
+              </a:rPr>
+              <a:t>–  no historical feed yet – scheduler accumulates it</a:t>
+            </a:r>
+          </a:p>
+          <a:p>
+            <a:pPr>
+              <a:spcBef>
+                <a:spcPts val="300"/>
+              </a:spcBef>
+            </a:pPr>
+            <a:r>
+              <a:rPr sz="1100">
+                <a:solidFill>
+                  <a:srgbClr val="595959"/>
+                </a:solidFill>
+                <a:latin typeface="Calibri"/>
+              </a:rPr>
+              <a:t>–  API unauthenticated until a gateway is added</a:t>
+            </a:r>
+          </a:p>
+        </p:txBody>
+      </p:sp>
+      <p:sp>
+        <p:nvSpPr>
+          <p:cNvPr id="11" name="Rounded Rectangle 10"/>
+          <p:cNvSpPr/>
+          <p:nvPr/>
+        </p:nvSpPr>
+        <p:spPr>
+          <a:xfrm>
+            <a:off x="4526280" y="1737360"/>
+            <a:ext cx="3520440" cy="4023360"/>
+          </a:xfrm>
+          <a:prstGeom prst="roundRect">
+            <a:avLst>
+              <a:gd name="adj" fmla="val 10000"/>
+            </a:avLst>
+          </a:prstGeom>
+          <a:solidFill>
+            <a:srgbClr val="F2F6FC"/>
+          </a:solidFill>
+          <a:ln w="9525">
+            <a:solidFill>
+              <a:srgbClr val="2E74B5"/>
+            </a:solidFill>
+          </a:ln>
+          <a:effectLst/>
+        </p:spPr>
+        <p:style>
+          <a:lnRef idx="1">
+            <a:schemeClr val="accent1"/>
+          </a:lnRef>
+          <a:fillRef idx="3">
+            <a:schemeClr val="accent1"/>
+          </a:fillRef>
+          <a:effectRef idx="2">
+            <a:schemeClr val="accent1"/>
+          </a:effectRef>
+          <a:fontRef idx="minor">
+            <a:schemeClr val="lt1"/>
+          </a:fontRef>
+        </p:style>
+        <p:txBody>
+          <a:bodyPr rtlCol="0" anchor="t" wrap="square" lIns="128016" rIns="128016" tIns="73152"/>
+          <a:lstStyle/>
+          <a:p>
+            <a:pPr algn="ctr"/>
+            <a:r>
+              <a:rPr b="1" sz="1300">
+                <a:solidFill>
+                  <a:srgbClr val="1F3864"/>
+                </a:solidFill>
+                <a:latin typeface="Calibri"/>
+              </a:rPr>
+              <a:t>Future</a:t>
+            </a:r>
+          </a:p>
+          <a:p>
+            <a:pPr>
+              <a:spcBef>
+                <a:spcPts val="300"/>
+              </a:spcBef>
+            </a:pPr>
+            <a:r>
+              <a:rPr sz="1100">
+                <a:solidFill>
+                  <a:srgbClr val="595959"/>
+                </a:solidFill>
+                <a:latin typeface="Calibri"/>
+              </a:rPr>
+              <a:t>–  retrain + revalidate on real ground truth</a:t>
+            </a:r>
+          </a:p>
+          <a:p>
+            <a:pPr>
+              <a:spcBef>
+                <a:spcPts val="300"/>
+              </a:spcBef>
+            </a:pPr>
+            <a:r>
+              <a:rPr sz="1100">
+                <a:solidFill>
+                  <a:srgbClr val="595959"/>
+                </a:solidFill>
+                <a:latin typeface="Calibri"/>
+              </a:rPr>
+              <a:t>–  gateway auth and rate limiting</a:t>
+            </a:r>
+          </a:p>
+          <a:p>
+            <a:pPr>
+              <a:spcBef>
+                <a:spcPts val="300"/>
+              </a:spcBef>
+            </a:pPr>
+            <a:r>
+              <a:rPr sz="1100">
+                <a:solidFill>
+                  <a:srgbClr val="595959"/>
+                </a:solidFill>
+                <a:latin typeface="Calibri"/>
+              </a:rPr>
+              <a:t>–  live TomTom + PostgreSQL round-trip in CI</a:t>
+            </a:r>
+          </a:p>
+          <a:p>
+            <a:pPr>
+              <a:spcBef>
+                <a:spcPts val="300"/>
+              </a:spcBef>
+            </a:pPr>
+            <a:r>
+              <a:rPr sz="1100">
+                <a:solidFill>
+                  <a:srgbClr val="595959"/>
+                </a:solidFill>
+                <a:latin typeface="Calibri"/>
+              </a:rPr>
+              <a:t>–  staging environment</a:t>
+            </a:r>
+          </a:p>
+        </p:txBody>
+      </p:sp>
+      <p:sp>
+        <p:nvSpPr>
+          <p:cNvPr id="12" name="Rounded Rectangle 11"/>
+          <p:cNvSpPr/>
+          <p:nvPr/>
+        </p:nvSpPr>
+        <p:spPr>
+          <a:xfrm>
+            <a:off x="8229600" y="1737360"/>
+            <a:ext cx="3154680" cy="4023360"/>
+          </a:xfrm>
+          <a:prstGeom prst="roundRect">
+            <a:avLst>
+              <a:gd name="adj" fmla="val 10000"/>
+            </a:avLst>
+          </a:prstGeom>
+          <a:solidFill>
+            <a:srgbClr val="F2F6FC"/>
+          </a:solidFill>
+          <a:ln w="9525">
+            <a:solidFill>
+              <a:srgbClr val="2E74B5"/>
+            </a:solidFill>
+          </a:ln>
+          <a:effectLst/>
+        </p:spPr>
+        <p:style>
+          <a:lnRef idx="1">
+            <a:schemeClr val="accent1"/>
+          </a:lnRef>
+          <a:fillRef idx="3">
+            <a:schemeClr val="accent1"/>
+          </a:fillRef>
+          <a:effectRef idx="2">
+            <a:schemeClr val="accent1"/>
+          </a:effectRef>
+          <a:fontRef idx="minor">
+            <a:schemeClr val="lt1"/>
+          </a:fontRef>
+        </p:style>
+        <p:txBody>
+          <a:bodyPr rtlCol="0" anchor="t" wrap="square" lIns="128016" rIns="128016" tIns="73152"/>
+          <a:lstStyle/>
+          <a:p>
+            <a:pPr algn="ctr"/>
+            <a:r>
+              <a:rPr b="1" sz="1300">
+                <a:solidFill>
+                  <a:srgbClr val="1F3864"/>
+                </a:solidFill>
+                <a:latin typeface="Calibri"/>
+              </a:rPr>
+              <a:t>Deployed now</a:t>
+            </a:r>
+          </a:p>
+          <a:p>
+            <a:pPr>
+              <a:spcBef>
+                <a:spcPts val="300"/>
+              </a:spcBef>
+            </a:pPr>
+            <a:r>
+              <a:rPr sz="1100">
+                <a:solidFill>
+                  <a:srgbClr val="595959"/>
+                </a:solidFill>
+                <a:latin typeface="Calibri"/>
+              </a:rPr>
+              <a:t>–  Docker image + docker-compose</a:t>
+            </a:r>
+          </a:p>
+          <a:p>
+            <a:pPr>
+              <a:spcBef>
+                <a:spcPts val="300"/>
+              </a:spcBef>
+            </a:pPr>
+            <a:r>
+              <a:rPr sz="1100">
+                <a:solidFill>
+                  <a:srgbClr val="595959"/>
+                </a:solidFill>
+                <a:latin typeface="Calibri"/>
+              </a:rPr>
+              <a:t>–  CI: 451 tests + image build, green</a:t>
+            </a:r>
+          </a:p>
+          <a:p>
+            <a:pPr>
+              <a:spcBef>
+                <a:spcPts val="300"/>
+              </a:spcBef>
+            </a:pPr>
+            <a:r>
+              <a:rPr sz="1100">
+                <a:solidFill>
+                  <a:srgbClr val="595959"/>
+                </a:solidFill>
+                <a:latin typeface="Calibri"/>
+              </a:rPr>
+              <a:t>–  single-URL public demo (Render)</a:t>
+            </a:r>
+          </a:p>
+          <a:p>
+            <a:pPr>
+              <a:spcBef>
+                <a:spcPts val="300"/>
+              </a:spcBef>
+            </a:pPr>
+            <a:r>
+              <a:rPr sz="1100">
+                <a:solidFill>
+                  <a:srgbClr val="595959"/>
+                </a:solidFill>
+                <a:latin typeface="Calibri"/>
+              </a:rPr>
+              <a:t>–  live TomTom collection enabled</a:t>
+            </a:r>
+          </a:p>
+        </p:txBody>
+      </p:sp>
+    </p:spTree>
+  </p:cSld>
+  <p:clrMapOvr>
+    <a:masterClrMapping/>
+  </p:clrMapOvr>
+</p:sld>
+</file>
+
+<file path=ppt/slides/slide13.xml><?xml version="1.0" encoding="utf-8"?>
+<p:sld xmlns:a="http://schemas.openxmlformats.org/drawingml/2006/main" xmlns:p="http://schemas.openxmlformats.org/presentationml/2006/main" xmlns:r="http://schemas.openxmlformats.org/officeDocument/2006/relationships">
+  <p:cSld>
+    <p:spTree>
+      <p:nvGrpSpPr>
+        <p:cNvPr id="1" name=""/>
+        <p:cNvGrpSpPr/>
+        <p:nvPr/>
+      </p:nvGrpSpPr>
+      <p:grpSpPr/>
+      <p:sp>
+        <p:nvSpPr>
+          <p:cNvPr id="2" name="Rectangle 1"/>
+          <p:cNvSpPr/>
+          <p:nvPr/>
+        </p:nvSpPr>
+        <p:spPr>
+          <a:xfrm>
+            <a:off x="0" y="0"/>
+            <a:ext cx="12191695" cy="6858000"/>
+          </a:xfrm>
+          <a:prstGeom prst="rect">
+            <a:avLst/>
+          </a:prstGeom>
+          <a:solidFill>
+            <a:srgbClr val="1F3864"/>
+          </a:solidFill>
+          <a:ln>
+            <a:noFill/>
+          </a:ln>
+          <a:effectLst/>
+        </p:spPr>
+        <p:style>
+          <a:lnRef idx="1">
+            <a:schemeClr val="accent1"/>
+          </a:lnRef>
+          <a:fillRef idx="3">
+            <a:schemeClr val="accent1"/>
+          </a:fillRef>
+          <a:effectRef idx="2">
+            <a:schemeClr val="accent1"/>
+          </a:effectRef>
+          <a:fontRef idx="minor">
+            <a:schemeClr val="lt1"/>
+          </a:fontRef>
+        </p:style>
+        <p:txBody>
+          <a:bodyPr rtlCol="0" anchor="ctr"/>
+          <a:lstStyle/>
+          <a:p>
+            <a:pPr algn="ctr"/>
+          </a:p>
+        </p:txBody>
+      </p:sp>
+      <p:sp>
+        <p:nvSpPr>
+          <p:cNvPr id="3" name="TextBox 2"/>
+          <p:cNvSpPr txBox="1"/>
+          <p:nvPr/>
+        </p:nvSpPr>
+        <p:spPr>
+          <a:xfrm>
+            <a:off x="822960" y="1188720"/>
+            <a:ext cx="10545775" cy="457200"/>
+          </a:xfrm>
+          <a:prstGeom prst="rect">
+            <a:avLst/>
+          </a:prstGeom>
+          <a:noFill/>
+        </p:spPr>
+        <p:txBody>
+          <a:bodyPr wrap="square" anchor="t">
+            <a:spAutoFit/>
+          </a:bodyPr>
+          <a:lstStyle/>
+          <a:p>
+            <a:pPr algn="ctr">
+              <a:spcBef>
+                <a:spcPts val="0"/>
+              </a:spcBef>
+              <a:spcAft>
+                <a:spcPts val="400"/>
+              </a:spcAft>
+            </a:pPr>
+            <a:r>
+              <a:rPr sz="1300" b="1" i="0">
+                <a:solidFill>
+                  <a:srgbClr val="9DC3E6"/>
+                </a:solidFill>
+                <a:latin typeface="Calibri"/>
+              </a:rPr>
+              <a:t>SLIDE 13 · CONCLUSION</a:t>
+            </a:r>
+          </a:p>
+        </p:txBody>
+      </p:sp>
+      <p:sp>
+        <p:nvSpPr>
+          <p:cNvPr id="4" name="TextBox 3"/>
+          <p:cNvSpPr txBox="1"/>
+          <p:nvPr/>
+        </p:nvSpPr>
+        <p:spPr>
+          <a:xfrm>
+            <a:off x="822960" y="1645920"/>
+            <a:ext cx="10545775" cy="822960"/>
+          </a:xfrm>
+          <a:prstGeom prst="rect">
+            <a:avLst/>
+          </a:prstGeom>
+          <a:noFill/>
+        </p:spPr>
+        <p:txBody>
+          <a:bodyPr wrap="square" anchor="t">
+            <a:spAutoFit/>
+          </a:bodyPr>
+          <a:lstStyle/>
+          <a:p>
+            <a:pPr algn="ctr">
+              <a:spcBef>
+                <a:spcPts val="0"/>
+              </a:spcBef>
+              <a:spcAft>
+                <a:spcPts val="400"/>
+              </a:spcAft>
+            </a:pPr>
+            <a:r>
+              <a:rPr sz="3400" b="1" i="0">
+                <a:solidFill>
+                  <a:srgbClr val="FFFFFF"/>
+                </a:solidFill>
+                <a:latin typeface="Calibri"/>
+              </a:rPr>
+              <a:t>A working, honest end-to-end pipeline</a:t>
+            </a:r>
+          </a:p>
+        </p:txBody>
+      </p:sp>
+      <p:sp>
+        <p:nvSpPr>
+          <p:cNvPr id="5" name="TextBox 4"/>
+          <p:cNvSpPr txBox="1"/>
+          <p:nvPr/>
+        </p:nvSpPr>
+        <p:spPr>
+          <a:xfrm>
+            <a:off x="1463040" y="2651760"/>
+            <a:ext cx="9265615" cy="2377440"/>
+          </a:xfrm>
+          <a:prstGeom prst="rect">
+            <a:avLst/>
+          </a:prstGeom>
+          <a:noFill/>
+        </p:spPr>
+        <p:txBody>
+          <a:bodyPr wrap="square" anchor="t">
+            <a:spAutoFit/>
+          </a:bodyPr>
+          <a:lstStyle/>
           <a:p>
             <a:pPr algn="l">
               <a:spcBef>
@@ -6454,7 +7171,7 @@
                 </a:solidFill>
                 <a:latin typeface="Calibri"/>
               </a:rPr>
-              <a:t>•  Collect → predict → visualise, verified by 450 automated tests.</a:t>
+              <a:t>•  Collect → predict → visualise, verified by 451 automated tests.</a:t>
             </a:r>
           </a:p>
           <a:p>
@@ -6511,7 +7228,7 @@
                 </a:solidFill>
                 <a:latin typeface="Calibri"/>
               </a:rPr>
-              <a:t>•  Ready for retraining, containerisation and public deployment hardening.</a:t>
+              <a:t>•  Containerised, CI-green and deployed at a public single URL – ready for retraining on real data and gateway hardening.</a:t>
             </a:r>
           </a:p>
         </p:txBody>

</xml_diff>